<commit_message>
Phase 0 complete: 18 tests green, Cora verified, requirements pinned
</commit_message>
<xml_diff>
--- a/slides/Weekly_Presentation_9.pptx
+++ b/slides/Weekly_Presentation_9.pptx
@@ -118,12 +118,12 @@
   <pc:docChgLst>
     <pc:chgData name="Ucchwas Talukder Utsha" userId="5d00aebb-9da7-4eec-b6b4-d48dd93a6925" providerId="ADAL" clId="{2696736A-EC31-4DCA-9887-52CDAA7E4777}"/>
     <pc:docChg chg="custSel modSld">
-      <pc:chgData name="Ucchwas Talukder Utsha" userId="5d00aebb-9da7-4eec-b6b4-d48dd93a6925" providerId="ADAL" clId="{2696736A-EC31-4DCA-9887-52CDAA7E4777}" dt="2026-08-25T21:53:13.656" v="3" actId="478"/>
+      <pc:chgData name="Ucchwas Talukder Utsha" userId="5d00aebb-9da7-4eec-b6b4-d48dd93a6925" providerId="ADAL" clId="{2696736A-EC31-4DCA-9887-52CDAA7E4777}" dt="2026-08-25T21:54:51.441" v="5" actId="20577"/>
       <pc:docMkLst>
         <pc:docMk/>
       </pc:docMkLst>
       <pc:sldChg chg="delSp modSp mod">
-        <pc:chgData name="Ucchwas Talukder Utsha" userId="5d00aebb-9da7-4eec-b6b4-d48dd93a6925" providerId="ADAL" clId="{2696736A-EC31-4DCA-9887-52CDAA7E4777}" dt="2026-08-25T21:53:13.656" v="3" actId="478"/>
+        <pc:chgData name="Ucchwas Talukder Utsha" userId="5d00aebb-9da7-4eec-b6b4-d48dd93a6925" providerId="ADAL" clId="{2696736A-EC31-4DCA-9887-52CDAA7E4777}" dt="2026-08-25T21:54:51.441" v="5" actId="20577"/>
         <pc:sldMkLst>
           <pc:docMk/>
           <pc:sldMk cId="3923863566" sldId="256"/>
@@ -158,6 +158,14 @@
             <pc:docMk/>
             <pc:sldMk cId="3923863566" sldId="256"/>
             <ac:spMk id="61" creationId="{351BC568-1D19-3F3F-48A7-F8C0BF9FE244}"/>
+          </ac:spMkLst>
+        </pc:spChg>
+        <pc:spChg chg="mod">
+          <ac:chgData name="Ucchwas Talukder Utsha" userId="5d00aebb-9da7-4eec-b6b4-d48dd93a6925" providerId="ADAL" clId="{2696736A-EC31-4DCA-9887-52CDAA7E4777}" dt="2026-08-25T21:54:51.441" v="5" actId="20577"/>
+          <ac:spMkLst>
+            <pc:docMk/>
+            <pc:sldMk cId="3923863566" sldId="256"/>
+            <ac:spMk id="84" creationId="{6971B7C5-9EE1-A42B-B4F8-BEA24E174D96}"/>
           </ac:spMkLst>
         </pc:spChg>
       </pc:sldChg>
@@ -7237,13 +7245,13 @@
           <a:p>
             <a:pPr algn="ctr"/>
             <a:r>
-              <a:rPr lang="en-US" sz="1600" b="1">
+              <a:rPr lang="en-US" sz="1600" b="1" dirty="0">
                 <a:solidFill>
                   <a:srgbClr val="FFFFFF"/>
                 </a:solidFill>
                 <a:latin typeface="Aptos" panose="020B0004020202020204" pitchFamily="34" charset="0"/>
               </a:rPr>
-              <a:t>All three help the LLM read a graph.  None of them returns a graph.</a:t>
+              <a:t>All three help the LLM read a graph.</a:t>
             </a:r>
           </a:p>
         </p:txBody>
@@ -7278,13 +7286,49 @@
           <a:lstStyle/>
           <a:p>
             <a:r>
-              <a:rPr lang="en-US" sz="1400">
+              <a:rPr lang="en-US" sz="1400" dirty="0">
                 <a:solidFill>
                   <a:srgbClr val="52657A"/>
                 </a:solidFill>
                 <a:latin typeface="Aptos" panose="020B0004020202020204" pitchFamily="34" charset="0"/>
               </a:rPr>
-              <a:t>Adjacency-row precedent (Yehudai et al., NeurIPS 2025): adjacency rows → Transformer → prediction; no pretrained LLM or graph output.</a:t>
+              <a:t>Adjacency-row precedent (</a:t>
+            </a:r>
+            <a:r>
+              <a:rPr lang="en-US" sz="1400" dirty="0" err="1">
+                <a:solidFill>
+                  <a:srgbClr val="52657A"/>
+                </a:solidFill>
+                <a:latin typeface="Aptos" panose="020B0004020202020204" pitchFamily="34" charset="0"/>
+              </a:rPr>
+              <a:t>Yehudai</a:t>
+            </a:r>
+            <a:r>
+              <a:rPr lang="en-US" sz="1400" dirty="0">
+                <a:solidFill>
+                  <a:srgbClr val="52657A"/>
+                </a:solidFill>
+                <a:latin typeface="Aptos" panose="020B0004020202020204" pitchFamily="34" charset="0"/>
+              </a:rPr>
+              <a:t> et al., </a:t>
+            </a:r>
+            <a:r>
+              <a:rPr lang="en-US" sz="1400" dirty="0" err="1">
+                <a:solidFill>
+                  <a:srgbClr val="52657A"/>
+                </a:solidFill>
+                <a:latin typeface="Aptos" panose="020B0004020202020204" pitchFamily="34" charset="0"/>
+              </a:rPr>
+              <a:t>NeurIPS</a:t>
+            </a:r>
+            <a:r>
+              <a:rPr lang="en-US" sz="1400" dirty="0">
+                <a:solidFill>
+                  <a:srgbClr val="52657A"/>
+                </a:solidFill>
+                <a:latin typeface="Aptos" panose="020B0004020202020204" pitchFamily="34" charset="0"/>
+              </a:rPr>
+              <a:t> 2025): adjacency rows → Transformer → prediction; no pretrained LLM or graph output.</a:t>
             </a:r>
           </a:p>
         </p:txBody>

</xml_diff>